<commit_message>
Lab 2: document 8,000-per-month data and ensemble champion v4
Update README, design doc, defense Q&A, screenshots and the Lab 2 deck
with the new numbers; integration test expects 8000/8000/2683.

Co-Authored-By: Claude Opus 5.5 <noreply@anthropic.com>
</commit_message>
<xml_diff>
--- a/docs/presentation/complaint-router-lab2.pptx
+++ b/docs/presentation/complaint-router-lab2.pptx
@@ -117,31 +117,31 @@
   <p:extLst>
     <p:ext uri="{521415D9-36F7-43E2-AB2F-B90AF26B5E84}">
       <p14:sectionLst xmlns:p14="http://schemas.microsoft.com/office/powerpoint/2010/main">
-        <p14:section name="Overview" id="{ec4fbc84-31cd-eda0-9078-8c99181033b1}">
+        <p14:section name="Overview" id="{522357b4-7560-d8eb-42c5-a5f24a8d63a5}">
           <p14:sldIdLst>
             <p14:sldId id="256"/>
             <p14:sldId id="257"/>
           </p14:sldIdLst>
         </p14:section>
-        <p14:section name="Data" id="{dcf8dced-264c-f65d-00f1-0fcfaee98785}">
+        <p14:section name="Data" id="{e4a85df7-8974-524d-432f-5a0125407fb9}">
           <p14:sldIdLst>
             <p14:sldId id="258"/>
           </p14:sldIdLst>
         </p14:section>
-        <p14:section name="Pipeline" id="{8c692aa1-8c07-1dce-2c81-dfeb4b31d1a4}">
+        <p14:section name="Pipeline" id="{7414acdf-47bb-debc-63f5-57ca18ad64e3}">
           <p14:sldIdLst>
             <p14:sldId id="259"/>
             <p14:sldId id="260"/>
             <p14:sldId id="261"/>
           </p14:sldIdLst>
         </p14:section>
-        <p14:section name="Model" id="{945ea358-51ac-7b06-cfcf-6cc3e9201ae4}">
+        <p14:section name="Model" id="{f8732e87-5439-1fcf-4a6d-5860343cd455}">
           <p14:sldIdLst>
             <p14:sldId id="262"/>
             <p14:sldId id="263"/>
           </p14:sldIdLst>
         </p14:section>
-        <p14:section name="Evidence" id="{8e678a62-aa20-7d27-dd25-c11b730a1dae}">
+        <p14:section name="Evidence" id="{8f4ed84e-e586-81e3-4801-9b35d23b83ca}">
           <p14:sldIdLst>
             <p14:sldId id="264"/>
             <p14:sldId id="265"/>
@@ -314,52 +314,52 @@
                 <c:formatCode>General</c:formatCode>
                 <c:ptCount val="18"/>
                 <c:pt idx="0">
-                  <c:v>38.9</c:v>
+                  <c:v>37.5</c:v>
                 </c:pt>
                 <c:pt idx="1">
-                  <c:v>26.8</c:v>
+                  <c:v>27.3</c:v>
                 </c:pt>
                 <c:pt idx="2">
-                  <c:v>26.9</c:v>
+                  <c:v>26.5</c:v>
                 </c:pt>
                 <c:pt idx="3">
-                  <c:v>24.6</c:v>
+                  <c:v>25.4</c:v>
                 </c:pt>
                 <c:pt idx="4">
-                  <c:v>26.7</c:v>
+                  <c:v>26.2</c:v>
                 </c:pt>
                 <c:pt idx="5">
-                  <c:v>27.9</c:v>
+                  <c:v>28.4</c:v>
                 </c:pt>
                 <c:pt idx="6">
-                  <c:v>27.1</c:v>
+                  <c:v>27.2</c:v>
                 </c:pt>
                 <c:pt idx="7">
-                  <c:v>21.1</c:v>
+                  <c:v>22.1</c:v>
                 </c:pt>
                 <c:pt idx="8">
-                  <c:v>16.2</c:v>
+                  <c:v>15.9</c:v>
                 </c:pt>
                 <c:pt idx="9">
                   <c:v>14.4</c:v>
                 </c:pt>
                 <c:pt idx="10">
-                  <c:v>15.8</c:v>
+                  <c:v>16</c:v>
                 </c:pt>
                 <c:pt idx="11">
-                  <c:v>10</c:v>
+                  <c:v>11</c:v>
                 </c:pt>
                 <c:pt idx="12">
-                  <c:v>3.6</c:v>
+                  <c:v>3.9</c:v>
                 </c:pt>
                 <c:pt idx="13">
-                  <c:v>2.8</c:v>
+                  <c:v>2.7</c:v>
                 </c:pt>
                 <c:pt idx="14">
-                  <c:v>3</c:v>
+                  <c:v>3.2</c:v>
                 </c:pt>
                 <c:pt idx="15">
-                  <c:v>3.8</c:v>
+                  <c:v>3.5</c:v>
                 </c:pt>
                 <c:pt idx="16">
                   <c:v>1</c:v>
@@ -865,7 +865,7 @@
                     <c:v>Keyword rule</c:v>
                   </c:pt>
                   <c:pt idx="2">
-                    <c:v>TF-IDF + LogReg</c:v>
+                    <c:v>TF-IDF ensemble</c:v>
                   </c:pt>
                 </c:lvl>
               </c:multiLvlStrCache>
@@ -878,13 +878,13 @@
                 <c:formatCode>General</c:formatCode>
                 <c:ptCount val="3"/>
                 <c:pt idx="0">
-                  <c:v>0.089</c:v>
+                  <c:v>0.088</c:v>
                 </c:pt>
                 <c:pt idx="1">
-                  <c:v>0.384</c:v>
+                  <c:v>0.38</c:v>
                 </c:pt>
                 <c:pt idx="2">
-                  <c:v>0.638</c:v>
+                  <c:v>0.633</c:v>
                 </c:pt>
               </c:numCache>
             </c:numRef>
@@ -3705,7 +3705,25 @@
                   <a:schemeClr val="accent5"/>
                 </a:solidFill>
               </a:rPr>
-              <a:t>KSE MLOps · Lab 2 · Zakhar Staryk · github.com/goodfrog33/kse-mlops-complaint-router · tag lab-2</a:t>
+              <a:t>KSE MLOps · Lab 2 · Zakhar Staryk · </a:t>
+            </a:r>
+            <a:pPr indent="0" marL="0">
+              <a:buNone/>
+            </a:pPr>
+            <a:r>
+              <a:rPr lang="en-US" sz="1200" u="sng" dirty="0">
+                <a:solidFill>
+                  <a:srgbClr val="9CC3E6"/>
+                </a:solidFill>
+                <a:hlinkClick r:id="rId1" invalidUrl="" action="" tgtFrame="" tooltip="Repository at tag lab-2" history="1" highlightClick="0" endSnd="0">
+                  <a:extLst>
+                    <a:ext uri="{A12FA001-AC4F-418D-AE19-62706E023703}">
+                      <ahyp:hlinkClr xmlns:ahyp="http://schemas.microsoft.com/office/drawing/2018/hyperlinkcolor" val="tx"/>
+                    </a:ext>
+                  </a:extLst>
+                </a:hlinkClick>
+              </a:rPr>
+              <a:t>github.com/goodfrog33/kse-mlops-complaint-router (tag lab-2)</a:t>
             </a:r>
             <a:endParaRPr lang="en-US" sz="1200" dirty="0"/>
           </a:p>
@@ -3813,7 +3831,7 @@
                   <a:schemeClr val="accent1"/>
                 </a:solidFill>
               </a:rPr>
-              <a:t>0.638 vs 0.384</a:t>
+              <a:t>0.633 vs 0.380</a:t>
             </a:r>
             <a:endParaRPr lang="en-US" sz="2800" dirty="0"/>
           </a:p>
@@ -4395,7 +4413,7 @@
                 <a:ea typeface="Courier New" pitchFamily="34" charset="-122"/>
                 <a:cs typeface="Courier New" pitchFamily="34" charset="-120"/>
               </a:rPr>
-              <a:t>version 2: commit 45cb4224fe, data 0319edfe…, test_macro_f1 0.6378</a:t>
+              <a:t>version 4: commit 5185a3a51b, data 6b6bda8b…, test_macro_f1 0.6325</a:t>
             </a:r>
             <a:endParaRPr lang="en-US" sz="1300" dirty="0"/>
           </a:p>
@@ -4415,7 +4433,7 @@
                 <a:ea typeface="Courier New" pitchFamily="34" charset="-122"/>
                 <a:cs typeface="Courier New" pitchFamily="34" charset="-120"/>
               </a:rPr>
-              <a:t>registered 0.6378  reproduced 0.6378  |diff| 0.0000  tolerance 0.005  -&gt; OK</a:t>
+              <a:t>registered 0.6325  reproduced 0.6325  |diff| 0.0000  tolerance 0.005  -&gt; OK</a:t>
             </a:r>
             <a:endParaRPr lang="en-US" sz="1300" dirty="0"/>
           </a:p>
@@ -4896,7 +4914,7 @@
                             <a:schemeClr val="tx1"/>
                           </a:solidFill>
                         </a:rPr>
-                        <a:t>make data-public restores 39 files, checksum 0bba9005…</a:t>
+                        <a:t>make data-public restores 39 files, checksum 872e979f…</a:t>
                       </a:r>
                       <a:endParaRPr lang="en-US" sz="1200" dirty="0"/>
                     </a:p>
@@ -5014,7 +5032,7 @@
                             <a:schemeClr val="tx1"/>
                           </a:solidFill>
                         </a:rPr>
-                        <a:t>2024-06 twice: 3000 / 3000 / 1013, same hash</a:t>
+                        <a:t>2024-06 twice: 8000 / 8000 / 2683, same hash</a:t>
                       </a:r>
                       <a:endParaRPr lang="en-US" sz="1200" dirty="0"/>
                     </a:p>
@@ -5368,7 +5386,7 @@
                             <a:schemeClr val="tx1"/>
                           </a:solidFill>
                         </a:rPr>
-                        <a:t>v2 @champion; make reproduce → diff 0.0000</a:t>
+                        <a:t>v4 @champion; make reproduce → diff 0.0000</a:t>
                       </a:r>
                       <a:endParaRPr lang="en-US" sz="1200" dirty="0"/>
                     </a:p>
@@ -5654,6 +5672,60 @@
               <a:t>CI: lint, unit and pipeline tests</a:t>
             </a:r>
             <a:endParaRPr lang="en-US" sz="1100" dirty="0"/>
+          </a:p>
+        </p:txBody>
+      </p:sp>
+      <p:sp>
+        <p:nvSpPr>
+          <p:cNvPr id="8" name="Text 5"/>
+          <p:cNvSpPr txBox="1"/>
+          <p:nvPr/>
+        </p:nvSpPr>
+        <p:spPr>
+          <a:xfrm>
+            <a:off x="457200" y="4389120"/>
+            <a:ext cx="8229600" cy="274320"/>
+          </a:xfrm>
+          <a:prstGeom prst="rect">
+            <a:avLst/>
+          </a:prstGeom>
+          <a:noFill/>
+          <a:ln/>
+        </p:spPr>
+        <p:txBody>
+          <a:bodyPr wrap="square" lIns="0" tIns="0" rIns="0" bIns="0" rtlCol="0" anchor="t"/>
+          <a:lstStyle/>
+          <a:p>
+            <a:pPr indent="0" marL="0">
+              <a:buNone/>
+            </a:pPr>
+            <a:r>
+              <a:rPr lang="en-US" sz="1200" dirty="0">
+                <a:solidFill>
+                  <a:schemeClr val="tx1"/>
+                </a:solidFill>
+              </a:rPr>
+              <a:t>Repository: </a:t>
+            </a:r>
+            <a:pPr indent="0" marL="0">
+              <a:buNone/>
+            </a:pPr>
+            <a:r>
+              <a:rPr lang="en-US" sz="1200" u="sng" dirty="0">
+                <a:solidFill>
+                  <a:schemeClr val="accent2"/>
+                </a:solidFill>
+                <a:hlinkClick r:id="rId1" invalidUrl="" action="" tgtFrame="" tooltip="Repository at tag lab-2" history="1" highlightClick="0" endSnd="0">
+                  <a:extLst>
+                    <a:ext uri="{A12FA001-AC4F-418D-AE19-62706E023703}">
+                      <ahyp:hlinkClr xmlns:ahyp="http://schemas.microsoft.com/office/drawing/2018/hyperlinkcolor" val="tx"/>
+                    </a:ext>
+                  </a:extLst>
+                </a:hlinkClick>
+              </a:rPr>
+              <a:t>github.com/goodfrog33/kse-mlops-complaint-router/tree/lab-2</a:t>
+            </a:r>
+            <a:endParaRPr lang="en-US" sz="1200" dirty="0"/>
           </a:p>
         </p:txBody>
       </p:sp>
@@ -5862,7 +5934,7 @@
                   <a:schemeClr val="tx1"/>
                 </a:solidFill>
               </a:rPr>
-              <a:t>117,000 complaints, 39 months, DVC</a:t>
+              <a:t>312,000 complaints, 39 months, DVC</a:t>
             </a:r>
             <a:endParaRPr lang="en-US" sz="1400" dirty="0"/>
           </a:p>
@@ -6225,7 +6297,7 @@
                   <a:schemeClr val="tx1"/>
                 </a:solidFill>
               </a:rPr>
-              <a:t>TF-IDF 0.638 vs keyword rule 0.384</a:t>
+              <a:t>TF-IDF ensemble 0.633 vs keyword rule 0.380</a:t>
             </a:r>
             <a:endParaRPr lang="en-US" sz="1400" dirty="0"/>
           </a:p>
@@ -6243,7 +6315,7 @@
                   <a:schemeClr val="tx1"/>
                 </a:solidFill>
               </a:rPr>
-              <a:t>MLflow v2 @champion, reproduced exactly</a:t>
+              <a:t>MLflow v4 @champion, reproduced exactly</a:t>
             </a:r>
             <a:endParaRPr lang="en-US" sz="1400" dirty="0"/>
           </a:p>
@@ -6456,7 +6528,7 @@
                             <a:schemeClr val="tx1"/>
                           </a:solidFill>
                         </a:rPr>
-                        <a:t>39 monthly CSVs × 3,000 complaints (66 MB)</a:t>
+                        <a:t>39 monthly CSVs × 8,000 complaints (168 MB)</a:t>
                       </a:r>
                       <a:endParaRPr lang="en-US" sz="1200" dirty="0"/>
                     </a:p>
@@ -6695,7 +6767,7 @@
                           <a:ea typeface="Courier New" pitchFamily="34" charset="-122"/>
                           <a:cs typeface="Courier New" pitchFamily="34" charset="-120"/>
                         </a:rPr>
-                        <a:t>0319edfe2ad83a39d4d8241602a462f8</a:t>
+                        <a:t>6b6bda8b4c8ece9715a5c9127a47dc8e</a:t>
                       </a:r>
                       <a:endParaRPr lang="en-US" sz="1200" dirty="0">
                         <a:latin typeface="Courier New" charset="0"/>
@@ -7056,7 +7128,7 @@
                           <a:ea typeface="Courier New" pitchFamily="34" charset="-122"/>
                           <a:cs typeface="Courier New" pitchFamily="34" charset="-120"/>
                         </a:rPr>
-                        <a:t>0bba9005abf7d408af110f7a192fc13a</a:t>
+                        <a:t>872e979f783b101ff87505a5a74b5838</a:t>
                       </a:r>
                       <a:endParaRPr lang="en-US" sz="1200" dirty="0">
                         <a:latin typeface="Courier New" charset="0"/>
@@ -7325,7 +7397,7 @@
                   <a:schemeClr val="accent5"/>
                 </a:solidFill>
               </a:rPr>
-              <a:t>hash 0319edfe…</a:t>
+              <a:t>hash 6b6bda8b…</a:t>
             </a:r>
             <a:endParaRPr lang="en-US" sz="1100" dirty="0"/>
           </a:p>
@@ -8480,7 +8552,7 @@
                   <a:schemeClr val="tx1"/>
                 </a:solidFill>
               </a:rPr>
-              <a:t>6 months at once: 39 in 113 s</a:t>
+              <a:t>6 months at once: 39 in 174 s</a:t>
             </a:r>
             <a:endParaRPr lang="en-US" sz="1300" dirty="0"/>
           </a:p>
@@ -9201,7 +9273,7 @@
                             <a:schemeClr val="tx1"/>
                           </a:solidFill>
                         </a:rPr>
-                        <a:t>3000</a:t>
+                        <a:t>8000</a:t>
                       </a:r>
                       <a:endParaRPr lang="en-US" sz="1300" dirty="0"/>
                     </a:p>
@@ -9319,7 +9391,7 @@
                             <a:schemeClr val="tx1"/>
                           </a:solidFill>
                         </a:rPr>
-                        <a:t>3000</a:t>
+                        <a:t>8000</a:t>
                       </a:r>
                       <a:endParaRPr lang="en-US" sz="1300" dirty="0"/>
                     </a:p>
@@ -9437,7 +9509,7 @@
                             <a:schemeClr val="tx1"/>
                           </a:solidFill>
                         </a:rPr>
-                        <a:t>1013</a:t>
+                        <a:t>2683</a:t>
                       </a:r>
                       <a:endParaRPr lang="en-US" sz="1300" dirty="0"/>
                     </a:p>
@@ -9827,7 +9899,7 @@
                             <a:schemeClr val="tx1"/>
                           </a:solidFill>
                         </a:rPr>
-                        <a:t>3000</a:t>
+                        <a:t>8000</a:t>
                       </a:r>
                       <a:endParaRPr lang="en-US" sz="1300" dirty="0"/>
                     </a:p>
@@ -9945,7 +10017,7 @@
                             <a:schemeClr val="tx1"/>
                           </a:solidFill>
                         </a:rPr>
-                        <a:t>3000</a:t>
+                        <a:t>8000</a:t>
                       </a:r>
                       <a:endParaRPr lang="en-US" sz="1300" dirty="0"/>
                     </a:p>
@@ -10063,7 +10135,7 @@
                             <a:schemeClr val="tx1"/>
                           </a:solidFill>
                         </a:rPr>
-                        <a:t>1013</a:t>
+                        <a:t>2683</a:t>
                       </a:r>
                       <a:endParaRPr lang="en-US" sz="1300" dirty="0"/>
                     </a:p>
@@ -10326,7 +10398,7 @@
                 <a:ea typeface="Courier New" pitchFamily="34" charset="-122"/>
                 <a:cs typeface="Courier New" pitchFamily="34" charset="-120"/>
               </a:rPr>
-              <a:t>e15aa30f…</a:t>
+              <a:t>30048bcc…</a:t>
             </a:r>
             <a:endParaRPr lang="en-US" sz="2400" dirty="0"/>
           </a:p>
@@ -12137,7 +12209,7 @@
                             <a:schemeClr val="tx1"/>
                           </a:solidFill>
                         </a:rPr>
-                        <a:t>Ally Financial</a:t>
+                        <a:t>Acima Credit</a:t>
                       </a:r>
                       <a:endParaRPr lang="en-US" sz="1200" dirty="0"/>
                     </a:p>
@@ -12195,7 +12267,7 @@
                             <a:schemeClr val="accent4"/>
                           </a:solidFill>
                         </a:rPr>
-                        <a:t>3</a:t>
+                        <a:t>5</a:t>
                       </a:r>
                       <a:endParaRPr lang="en-US" sz="1200" dirty="0"/>
                     </a:p>
@@ -12253,7 +12325,183 @@
                             <a:schemeClr val="tx1"/>
                           </a:solidFill>
                         </a:rPr>
-                        <a:t>5</a:t>
+                        <a:t>1</a:t>
+                      </a:r>
+                      <a:endParaRPr lang="en-US" sz="1200" dirty="0"/>
+                    </a:p>
+                  </a:txBody>
+                  <a:tcPr marL="54864" marR="54864" marT="54864" marB="54864" anchor="ctr">
+                    <a:lnL w="6350" cap="flat" cmpd="sng" algn="ctr">
+                      <a:solidFill>
+                        <a:srgbClr val="D3DAE2"/>
+                      </a:solidFill>
+                      <a:prstDash val="solid"/>
+                      <a:round/>
+                      <a:headEnd type="none" w="med" len="med"/>
+                      <a:tailEnd type="none" w="med" len="med"/>
+                    </a:lnL>
+                    <a:lnR w="6350" cap="flat" cmpd="sng" algn="ctr">
+                      <a:solidFill>
+                        <a:srgbClr val="D3DAE2"/>
+                      </a:solidFill>
+                      <a:prstDash val="solid"/>
+                      <a:round/>
+                      <a:headEnd type="none" w="med" len="med"/>
+                      <a:tailEnd type="none" w="med" len="med"/>
+                    </a:lnR>
+                    <a:lnT w="6350" cap="flat" cmpd="sng" algn="ctr">
+                      <a:solidFill>
+                        <a:srgbClr val="D3DAE2"/>
+                      </a:solidFill>
+                      <a:prstDash val="solid"/>
+                      <a:round/>
+                      <a:headEnd type="none" w="med" len="med"/>
+                      <a:tailEnd type="none" w="med" len="med"/>
+                    </a:lnT>
+                    <a:lnB w="6350" cap="flat" cmpd="sng" algn="ctr">
+                      <a:solidFill>
+                        <a:srgbClr val="D3DAE2"/>
+                      </a:solidFill>
+                      <a:prstDash val="solid"/>
+                      <a:round/>
+                      <a:headEnd type="none" w="med" len="med"/>
+                      <a:tailEnd type="none" w="med" len="med"/>
+                    </a:lnB>
+                  </a:tcPr>
+                </a:tc>
+              </a:tr>
+              <a:tr h="384048">
+                <a:tc>
+                  <a:txBody>
+                    <a:bodyPr/>
+                    <a:lstStyle/>
+                    <a:p>
+                      <a:pPr indent="0" marL="0">
+                        <a:buNone/>
+                      </a:pPr>
+                      <a:r>
+                        <a:rPr lang="en-US" sz="1200" dirty="0">
+                          <a:solidFill>
+                            <a:schemeClr val="tx1"/>
+                          </a:solidFill>
+                        </a:rPr>
+                        <a:t>Ally Financial</a:t>
+                      </a:r>
+                      <a:endParaRPr lang="en-US" sz="1200" dirty="0"/>
+                    </a:p>
+                  </a:txBody>
+                  <a:tcPr marL="54864" marR="54864" marT="54864" marB="54864" anchor="ctr">
+                    <a:lnL w="6350" cap="flat" cmpd="sng" algn="ctr">
+                      <a:solidFill>
+                        <a:srgbClr val="D3DAE2"/>
+                      </a:solidFill>
+                      <a:prstDash val="solid"/>
+                      <a:round/>
+                      <a:headEnd type="none" w="med" len="med"/>
+                      <a:tailEnd type="none" w="med" len="med"/>
+                    </a:lnL>
+                    <a:lnR w="6350" cap="flat" cmpd="sng" algn="ctr">
+                      <a:solidFill>
+                        <a:srgbClr val="D3DAE2"/>
+                      </a:solidFill>
+                      <a:prstDash val="solid"/>
+                      <a:round/>
+                      <a:headEnd type="none" w="med" len="med"/>
+                      <a:tailEnd type="none" w="med" len="med"/>
+                    </a:lnR>
+                    <a:lnT w="6350" cap="flat" cmpd="sng" algn="ctr">
+                      <a:solidFill>
+                        <a:srgbClr val="D3DAE2"/>
+                      </a:solidFill>
+                      <a:prstDash val="solid"/>
+                      <a:round/>
+                      <a:headEnd type="none" w="med" len="med"/>
+                      <a:tailEnd type="none" w="med" len="med"/>
+                    </a:lnT>
+                    <a:lnB w="6350" cap="flat" cmpd="sng" algn="ctr">
+                      <a:solidFill>
+                        <a:srgbClr val="D3DAE2"/>
+                      </a:solidFill>
+                      <a:prstDash val="solid"/>
+                      <a:round/>
+                      <a:headEnd type="none" w="med" len="med"/>
+                      <a:tailEnd type="none" w="med" len="med"/>
+                    </a:lnB>
+                  </a:tcPr>
+                </a:tc>
+                <a:tc>
+                  <a:txBody>
+                    <a:bodyPr/>
+                    <a:lstStyle/>
+                    <a:p>
+                      <a:pPr algn="r" indent="0" marL="0">
+                        <a:buNone/>
+                      </a:pPr>
+                      <a:r>
+                        <a:rPr lang="en-US" sz="1200" b="1" dirty="0">
+                          <a:solidFill>
+                            <a:schemeClr val="accent4"/>
+                          </a:solidFill>
+                        </a:rPr>
+                        <a:t>7</a:t>
+                      </a:r>
+                      <a:endParaRPr lang="en-US" sz="1200" dirty="0"/>
+                    </a:p>
+                  </a:txBody>
+                  <a:tcPr marL="54864" marR="54864" marT="54864" marB="54864" anchor="ctr">
+                    <a:lnL w="6350" cap="flat" cmpd="sng" algn="ctr">
+                      <a:solidFill>
+                        <a:srgbClr val="D3DAE2"/>
+                      </a:solidFill>
+                      <a:prstDash val="solid"/>
+                      <a:round/>
+                      <a:headEnd type="none" w="med" len="med"/>
+                      <a:tailEnd type="none" w="med" len="med"/>
+                    </a:lnL>
+                    <a:lnR w="6350" cap="flat" cmpd="sng" algn="ctr">
+                      <a:solidFill>
+                        <a:srgbClr val="D3DAE2"/>
+                      </a:solidFill>
+                      <a:prstDash val="solid"/>
+                      <a:round/>
+                      <a:headEnd type="none" w="med" len="med"/>
+                      <a:tailEnd type="none" w="med" len="med"/>
+                    </a:lnR>
+                    <a:lnT w="6350" cap="flat" cmpd="sng" algn="ctr">
+                      <a:solidFill>
+                        <a:srgbClr val="D3DAE2"/>
+                      </a:solidFill>
+                      <a:prstDash val="solid"/>
+                      <a:round/>
+                      <a:headEnd type="none" w="med" len="med"/>
+                      <a:tailEnd type="none" w="med" len="med"/>
+                    </a:lnT>
+                    <a:lnB w="6350" cap="flat" cmpd="sng" algn="ctr">
+                      <a:solidFill>
+                        <a:srgbClr val="D3DAE2"/>
+                      </a:solidFill>
+                      <a:prstDash val="solid"/>
+                      <a:round/>
+                      <a:headEnd type="none" w="med" len="med"/>
+                      <a:tailEnd type="none" w="med" len="med"/>
+                    </a:lnB>
+                  </a:tcPr>
+                </a:tc>
+                <a:tc>
+                  <a:txBody>
+                    <a:bodyPr/>
+                    <a:lstStyle/>
+                    <a:p>
+                      <a:pPr algn="r" indent="0" marL="0">
+                        <a:buNone/>
+                      </a:pPr>
+                      <a:r>
+                        <a:rPr lang="en-US" sz="1200" dirty="0">
+                          <a:solidFill>
+                            <a:schemeClr val="tx1"/>
+                          </a:solidFill>
+                        </a:rPr>
+                        <a:t>13</a:t>
                       </a:r>
                       <a:endParaRPr lang="en-US" sz="1200" dirty="0"/>
                     </a:p>
@@ -12371,7 +12619,7 @@
                             <a:schemeClr val="accent4"/>
                           </a:solidFill>
                         </a:rPr>
-                        <a:t>6</a:t>
+                        <a:t>22</a:t>
                       </a:r>
                       <a:endParaRPr lang="en-US" sz="1200" dirty="0"/>
                     </a:p>
@@ -12429,183 +12677,7 @@
                             <a:schemeClr val="tx1"/>
                           </a:solidFill>
                         </a:rPr>
-                        <a:t>8</a:t>
-                      </a:r>
-                      <a:endParaRPr lang="en-US" sz="1200" dirty="0"/>
-                    </a:p>
-                  </a:txBody>
-                  <a:tcPr marL="54864" marR="54864" marT="54864" marB="54864" anchor="ctr">
-                    <a:lnL w="6350" cap="flat" cmpd="sng" algn="ctr">
-                      <a:solidFill>
-                        <a:srgbClr val="D3DAE2"/>
-                      </a:solidFill>
-                      <a:prstDash val="solid"/>
-                      <a:round/>
-                      <a:headEnd type="none" w="med" len="med"/>
-                      <a:tailEnd type="none" w="med" len="med"/>
-                    </a:lnL>
-                    <a:lnR w="6350" cap="flat" cmpd="sng" algn="ctr">
-                      <a:solidFill>
-                        <a:srgbClr val="D3DAE2"/>
-                      </a:solidFill>
-                      <a:prstDash val="solid"/>
-                      <a:round/>
-                      <a:headEnd type="none" w="med" len="med"/>
-                      <a:tailEnd type="none" w="med" len="med"/>
-                    </a:lnR>
-                    <a:lnT w="6350" cap="flat" cmpd="sng" algn="ctr">
-                      <a:solidFill>
-                        <a:srgbClr val="D3DAE2"/>
-                      </a:solidFill>
-                      <a:prstDash val="solid"/>
-                      <a:round/>
-                      <a:headEnd type="none" w="med" len="med"/>
-                      <a:tailEnd type="none" w="med" len="med"/>
-                    </a:lnT>
-                    <a:lnB w="6350" cap="flat" cmpd="sng" algn="ctr">
-                      <a:solidFill>
-                        <a:srgbClr val="D3DAE2"/>
-                      </a:solidFill>
-                      <a:prstDash val="solid"/>
-                      <a:round/>
-                      <a:headEnd type="none" w="med" len="med"/>
-                      <a:tailEnd type="none" w="med" len="med"/>
-                    </a:lnB>
-                  </a:tcPr>
-                </a:tc>
-              </a:tr>
-              <a:tr h="384048">
-                <a:tc>
-                  <a:txBody>
-                    <a:bodyPr/>
-                    <a:lstStyle/>
-                    <a:p>
-                      <a:pPr indent="0" marL="0">
-                        <a:buNone/>
-                      </a:pPr>
-                      <a:r>
-                        <a:rPr lang="en-US" sz="1200" dirty="0">
-                          <a:solidFill>
-                            <a:schemeClr val="tx1"/>
-                          </a:solidFill>
-                        </a:rPr>
-                        <a:t>Affirm</a:t>
-                      </a:r>
-                      <a:endParaRPr lang="en-US" sz="1200" dirty="0"/>
-                    </a:p>
-                  </a:txBody>
-                  <a:tcPr marL="54864" marR="54864" marT="54864" marB="54864" anchor="ctr">
-                    <a:lnL w="6350" cap="flat" cmpd="sng" algn="ctr">
-                      <a:solidFill>
-                        <a:srgbClr val="D3DAE2"/>
-                      </a:solidFill>
-                      <a:prstDash val="solid"/>
-                      <a:round/>
-                      <a:headEnd type="none" w="med" len="med"/>
-                      <a:tailEnd type="none" w="med" len="med"/>
-                    </a:lnL>
-                    <a:lnR w="6350" cap="flat" cmpd="sng" algn="ctr">
-                      <a:solidFill>
-                        <a:srgbClr val="D3DAE2"/>
-                      </a:solidFill>
-                      <a:prstDash val="solid"/>
-                      <a:round/>
-                      <a:headEnd type="none" w="med" len="med"/>
-                      <a:tailEnd type="none" w="med" len="med"/>
-                    </a:lnR>
-                    <a:lnT w="6350" cap="flat" cmpd="sng" algn="ctr">
-                      <a:solidFill>
-                        <a:srgbClr val="D3DAE2"/>
-                      </a:solidFill>
-                      <a:prstDash val="solid"/>
-                      <a:round/>
-                      <a:headEnd type="none" w="med" len="med"/>
-                      <a:tailEnd type="none" w="med" len="med"/>
-                    </a:lnT>
-                    <a:lnB w="6350" cap="flat" cmpd="sng" algn="ctr">
-                      <a:solidFill>
-                        <a:srgbClr val="D3DAE2"/>
-                      </a:solidFill>
-                      <a:prstDash val="solid"/>
-                      <a:round/>
-                      <a:headEnd type="none" w="med" len="med"/>
-                      <a:tailEnd type="none" w="med" len="med"/>
-                    </a:lnB>
-                  </a:tcPr>
-                </a:tc>
-                <a:tc>
-                  <a:txBody>
-                    <a:bodyPr/>
-                    <a:lstStyle/>
-                    <a:p>
-                      <a:pPr algn="r" indent="0" marL="0">
-                        <a:buNone/>
-                      </a:pPr>
-                      <a:r>
-                        <a:rPr lang="en-US" sz="1200" b="1" dirty="0">
-                          <a:solidFill>
-                            <a:schemeClr val="accent4"/>
-                          </a:solidFill>
-                        </a:rPr>
-                        <a:t>4</a:t>
-                      </a:r>
-                      <a:endParaRPr lang="en-US" sz="1200" dirty="0"/>
-                    </a:p>
-                  </a:txBody>
-                  <a:tcPr marL="54864" marR="54864" marT="54864" marB="54864" anchor="ctr">
-                    <a:lnL w="6350" cap="flat" cmpd="sng" algn="ctr">
-                      <a:solidFill>
-                        <a:srgbClr val="D3DAE2"/>
-                      </a:solidFill>
-                      <a:prstDash val="solid"/>
-                      <a:round/>
-                      <a:headEnd type="none" w="med" len="med"/>
-                      <a:tailEnd type="none" w="med" len="med"/>
-                    </a:lnL>
-                    <a:lnR w="6350" cap="flat" cmpd="sng" algn="ctr">
-                      <a:solidFill>
-                        <a:srgbClr val="D3DAE2"/>
-                      </a:solidFill>
-                      <a:prstDash val="solid"/>
-                      <a:round/>
-                      <a:headEnd type="none" w="med" len="med"/>
-                      <a:tailEnd type="none" w="med" len="med"/>
-                    </a:lnR>
-                    <a:lnT w="6350" cap="flat" cmpd="sng" algn="ctr">
-                      <a:solidFill>
-                        <a:srgbClr val="D3DAE2"/>
-                      </a:solidFill>
-                      <a:prstDash val="solid"/>
-                      <a:round/>
-                      <a:headEnd type="none" w="med" len="med"/>
-                      <a:tailEnd type="none" w="med" len="med"/>
-                    </a:lnT>
-                    <a:lnB w="6350" cap="flat" cmpd="sng" algn="ctr">
-                      <a:solidFill>
-                        <a:srgbClr val="D3DAE2"/>
-                      </a:solidFill>
-                      <a:prstDash val="solid"/>
-                      <a:round/>
-                      <a:headEnd type="none" w="med" len="med"/>
-                      <a:tailEnd type="none" w="med" len="med"/>
-                    </a:lnB>
-                  </a:tcPr>
-                </a:tc>
-                <a:tc>
-                  <a:txBody>
-                    <a:bodyPr/>
-                    <a:lstStyle/>
-                    <a:p>
-                      <a:pPr algn="r" indent="0" marL="0">
-                        <a:buNone/>
-                      </a:pPr>
-                      <a:r>
-                        <a:rPr lang="en-US" sz="1200" dirty="0">
-                          <a:solidFill>
-                            <a:schemeClr val="tx1"/>
-                          </a:solidFill>
-                        </a:rPr>
-                        <a:t>3</a:t>
+                        <a:t>23</a:t>
                       </a:r>
                       <a:endParaRPr lang="en-US" sz="1200" dirty="0"/>
                     </a:p>
@@ -13165,7 +13237,7 @@
                             <a:schemeClr val="tx1"/>
                           </a:solidFill>
                         </a:rPr>
-                        <a:t>0.652</a:t>
+                        <a:t>0.615</a:t>
                       </a:r>
                       <a:endParaRPr lang="en-US" sz="1200" dirty="0"/>
                     </a:p>
@@ -13223,7 +13295,7 @@
                             <a:schemeClr val="tx1"/>
                           </a:solidFill>
                         </a:rPr>
-                        <a:t>0.374</a:t>
+                        <a:t>0.386</a:t>
                       </a:r>
                       <a:endParaRPr lang="en-US" sz="1200" dirty="0"/>
                     </a:p>
@@ -13341,7 +13413,7 @@
                             <a:schemeClr val="tx1"/>
                           </a:solidFill>
                         </a:rPr>
-                        <a:t>0.682</a:t>
+                        <a:t>0.714</a:t>
                       </a:r>
                       <a:endParaRPr lang="en-US" sz="1200" dirty="0"/>
                     </a:p>
@@ -13399,7 +13471,7 @@
                             <a:schemeClr val="tx1"/>
                           </a:solidFill>
                         </a:rPr>
-                        <a:t>0.377</a:t>
+                        <a:t>0.381</a:t>
                       </a:r>
                       <a:endParaRPr lang="en-US" sz="1200" dirty="0"/>
                     </a:p>
@@ -13517,7 +13589,7 @@
                             <a:schemeClr val="tx1"/>
                           </a:solidFill>
                         </a:rPr>
-                        <a:t>0.716</a:t>
+                        <a:t>0.618</a:t>
                       </a:r>
                       <a:endParaRPr lang="en-US" sz="1200" dirty="0"/>
                     </a:p>
@@ -13575,7 +13647,7 @@
                             <a:schemeClr val="tx1"/>
                           </a:solidFill>
                         </a:rPr>
-                        <a:t>0.405</a:t>
+                        <a:t>0.375</a:t>
                       </a:r>
                       <a:endParaRPr lang="en-US" sz="1200" dirty="0"/>
                     </a:p>
@@ -13693,7 +13765,7 @@
                             <a:schemeClr val="accent4"/>
                           </a:solidFill>
                         </a:rPr>
-                        <a:t>0.684 ± 0.026</a:t>
+                        <a:t>0.649 ± 0.046</a:t>
                       </a:r>
                       <a:endParaRPr lang="en-US" sz="1200" dirty="0"/>
                     </a:p>
@@ -13751,7 +13823,7 @@
                             <a:schemeClr val="tx1"/>
                           </a:solidFill>
                         </a:rPr>
-                        <a:t>0.385 ± 0.014</a:t>
+                        <a:t>0.381 ± 0.004</a:t>
                       </a:r>
                       <a:endParaRPr lang="en-US" sz="1200" dirty="0"/>
                     </a:p>
@@ -13857,7 +13929,7 @@
                   <a:schemeClr val="accent1"/>
                 </a:solidFill>
               </a:rPr>
-              <a:t>Random split: 0.591</a:t>
+              <a:t>Random split: 0.688</a:t>
             </a:r>
             <a:endParaRPr lang="en-US" sz="1500" dirty="0"/>
           </a:p>
@@ -13893,7 +13965,7 @@
                   <a:schemeClr val="tx1"/>
                 </a:solidFill>
               </a:rPr>
-              <a:t>No inflation on this uniform 0.5% sample; time split kept because it matches use</a:t>
+              <a:t>+0.055 too optimistic: it trains on months after the test. Time split matches use</a:t>
             </a:r>
             <a:endParaRPr lang="en-US" sz="1200" dirty="0"/>
           </a:p>
@@ -14009,7 +14081,7 @@
       </p:sp>
       <p:pic>
         <p:nvPicPr>
-          <p:cNvPr id="3" name="Image 0" descr="/Users/zakharstaryk/PycharmProjects/kse-mlops-complaint-router/docs/img/mlflow_model_v2.png">    </p:cNvPr>
+          <p:cNvPr id="3" name="Image 0" descr="/Users/zakharstaryk/PycharmProjects/kse-mlops-complaint-router/docs/img/mlflow_model_champion.png">    </p:cNvPr>
           <p:cNvPicPr>
             <a:picLocks noChangeAspect="1"/>
           </p:cNvPicPr>
@@ -14223,7 +14295,7 @@
                   <a:schemeClr val="tx1"/>
                 </a:solidFill>
               </a:rPr>
-              <a:t>complaint-router v2 · @champion</a:t>
+              <a:t>complaint-router v4 · @champion</a:t>
             </a:r>
             <a:endParaRPr lang="en-US" sz="1300" dirty="0"/>
           </a:p>

</xml_diff>